<commit_message>
Add maps and plans to the decks
Two slides after the camera that follows an object, where they belong rather
than as an appendix: cameras on a map of the site, and a fixed camera driving
a PTZ through the map. Screenshots are from the OnvifSim bench. The agenda,
the title, the closing summary and the technical table mention maps too; the
table's cell padding is tighter so the ninth row clears the browser note.

PDFs re-rendered from the same sources.

Co-Authored-By: Claude Opus 5.5 <noreply@anthropic.com>
</commit_message>
<xml_diff>
--- a/docs/TreeAlarm-VMS-2026-en.pptx
+++ b/docs/TreeAlarm-VMS-2026-en.pptx
@@ -12,6 +12,8 @@
     <p:sldId id="260" r:id="rId11"/>
     <p:sldId id="261" r:id="rId12"/>
     <p:sldId id="288" r:id="rId39"/>
+    <p:sldId id="290" r:id="rId41"/>
+    <p:sldId id="291" r:id="rId42"/>
     <p:sldId id="262" r:id="rId13"/>
     <p:sldId id="263" r:id="rId14"/>
     <p:sldId id="264" r:id="rId15"/>
@@ -3407,7 +3409,7 @@
                 </a:solidFill>
                 <a:latin typeface="Calibri"/>
               </a:rPr>
-              <a:t>System overview · new: the camera follows an object by itself · finding a person across every camera · less disk space used · link with the TreeAlarm monitoring map · 2026</a:t>
+              <a:t>System overview · new: cameras on a map of the site · the camera follows an object by itself · finding a person across every camera · less disk space used · link with the TreeAlarm monitoring map · 2026</a:t>
             </a:r>
           </a:p>
         </p:txBody>
@@ -3737,7 +3739,7 @@
                 </a:solidFill>
                 <a:latin typeface="Calibri"/>
               </a:rPr>
-              <a:t>11</a:t>
+              <a:t>13</a:t>
             </a:r>
           </a:p>
         </p:txBody>
@@ -4180,7 +4182,7 @@
                 </a:solidFill>
                 <a:latin typeface="Calibri"/>
               </a:rPr>
-              <a:t>12</a:t>
+              <a:t>14</a:t>
             </a:r>
           </a:p>
         </p:txBody>
@@ -4488,7 +4490,7 @@
                 </a:solidFill>
                 <a:latin typeface="Calibri"/>
               </a:rPr>
-              <a:t>13</a:t>
+              <a:t>15</a:t>
             </a:r>
           </a:p>
         </p:txBody>
@@ -4887,7 +4889,7 @@
                 </a:solidFill>
                 <a:latin typeface="Calibri"/>
               </a:rPr>
-              <a:t>15</a:t>
+              <a:t>17</a:t>
             </a:r>
           </a:p>
         </p:txBody>
@@ -5286,7 +5288,7 @@
                 </a:solidFill>
                 <a:latin typeface="Calibri"/>
               </a:rPr>
-              <a:t>16</a:t>
+              <a:t>18</a:t>
             </a:r>
           </a:p>
         </p:txBody>
@@ -5572,7 +5574,7 @@
                 </a:solidFill>
                 <a:latin typeface="Calibri"/>
               </a:rPr>
-              <a:t>17</a:t>
+              <a:t>19</a:t>
             </a:r>
           </a:p>
         </p:txBody>
@@ -5880,7 +5882,7 @@
                 </a:solidFill>
                 <a:latin typeface="Calibri"/>
               </a:rPr>
-              <a:t>18</a:t>
+              <a:t>20</a:t>
             </a:r>
           </a:p>
         </p:txBody>
@@ -6429,7 +6431,7 @@
                 </a:solidFill>
                 <a:latin typeface="Calibri"/>
               </a:rPr>
-              <a:t>20</a:t>
+              <a:t>22</a:t>
             </a:r>
           </a:p>
         </p:txBody>
@@ -7266,7 +7268,7 @@
                 </a:solidFill>
                 <a:latin typeface="Calibri"/>
               </a:rPr>
-              <a:t>21</a:t>
+              <a:t>23</a:t>
             </a:r>
           </a:p>
         </p:txBody>
@@ -7462,6 +7464,28 @@
                 </a:solidFill>
                 <a:latin typeface="Calibri"/>
               </a:rPr>
+              <a:t>•   New: cameras on a map of the site and its floor plans, and a PTZ camera that follows whatever a fixed camera sees.</a:t>
+            </a:r>
+          </a:p>
+          <a:p>
+            <a:pPr algn="l" marL="237744" indent="-237744">
+              <a:lnSpc>
+                <a:spcPct val="112000"/>
+              </a:lnSpc>
+              <a:spcBef>
+                <a:spcPts val="0"/>
+              </a:spcBef>
+              <a:spcAft>
+                <a:spcPts val="1100"/>
+              </a:spcAft>
+            </a:pPr>
+            <a:r>
+              <a:rPr sz="1600" b="0">
+                <a:solidFill>
+                  <a:srgbClr val="3E4C59"/>
+                </a:solidFill>
+                <a:latin typeface="Calibri"/>
+              </a:rPr>
               <a:t>•   New: the archive shrinks itself — what matters in the frame stays sharp, and noticeably less space is needed.</a:t>
             </a:r>
           </a:p>
@@ -7973,7 +7997,7 @@
                 </a:solidFill>
                 <a:latin typeface="Calibri"/>
               </a:rPr>
-              <a:t>22</a:t>
+              <a:t>24</a:t>
             </a:r>
           </a:p>
         </p:txBody>
@@ -8372,7 +8396,7 @@
                 </a:solidFill>
                 <a:latin typeface="Calibri"/>
               </a:rPr>
-              <a:t>23</a:t>
+              <a:t>25</a:t>
             </a:r>
           </a:p>
         </p:txBody>
@@ -8680,7 +8704,7 @@
                 </a:solidFill>
                 <a:latin typeface="Calibri"/>
               </a:rPr>
-              <a:t>24</a:t>
+              <a:t>26</a:t>
             </a:r>
           </a:p>
         </p:txBody>
@@ -9342,7 +9366,7 @@
                 </a:solidFill>
                 <a:latin typeface="Calibri"/>
               </a:rPr>
-              <a:t>26</a:t>
+              <a:t>28</a:t>
             </a:r>
           </a:p>
         </p:txBody>
@@ -9832,7 +9856,7 @@
                 </a:solidFill>
                 <a:latin typeface="Calibri"/>
               </a:rPr>
-              <a:t>27</a:t>
+              <a:t>29</a:t>
             </a:r>
           </a:p>
         </p:txBody>
@@ -10297,7 +10321,7 @@
                 </a:solidFill>
                 <a:latin typeface="Calibri"/>
               </a:rPr>
-              <a:t>28</a:t>
+              <a:t>30</a:t>
             </a:r>
           </a:p>
         </p:txBody>
@@ -10627,7 +10651,7 @@
                 </a:solidFill>
                 <a:latin typeface="Calibri"/>
               </a:rPr>
-              <a:t>29</a:t>
+              <a:t>31</a:t>
             </a:r>
           </a:p>
         </p:txBody>
@@ -11326,7 +11350,7 @@
                 </a:solidFill>
                 <a:latin typeface="Calibri"/>
               </a:rPr>
-              <a:t>30</a:t>
+              <a:t>32</a:t>
             </a:r>
           </a:p>
         </p:txBody>
@@ -11930,7 +11954,7 @@
         </p:nvGraphicFramePr>
         <p:xfrm>
           <a:off x="685800" y="1572768"/>
-          <a:ext cx="10820095" cy="3511296"/>
+          <a:ext cx="10820095" cy="3950208"/>
         </p:xfrm>
         <a:graphic>
           <a:graphicData uri="http://schemas.openxmlformats.org/drawingml/2006/table">
@@ -11970,7 +11994,7 @@
                       </a:r>
                     </a:p>
                   </a:txBody>
-                  <a:tcPr marL="146304" marR="146304" marT="64008" marB="64008" anchor="ctr">
+                  <a:tcPr marL="146304" marR="146304" marT="27432" marB="27432" anchor="ctr">
                     <a:solidFill>
                       <a:srgbClr val="F5F7FA"/>
                     </a:solidFill>
@@ -12003,7 +12027,7 @@
                       </a:r>
                     </a:p>
                   </a:txBody>
-                  <a:tcPr marL="146304" marR="146304" marT="64008" marB="64008" anchor="ctr">
+                  <a:tcPr marL="146304" marR="146304" marT="27432" marB="27432" anchor="ctr">
                     <a:solidFill>
                       <a:srgbClr val="F5F7FA"/>
                     </a:solidFill>
@@ -12038,7 +12062,7 @@
                       </a:r>
                     </a:p>
                   </a:txBody>
-                  <a:tcPr marL="146304" marR="146304" marT="64008" marB="64008" anchor="ctr">
+                  <a:tcPr marL="146304" marR="146304" marT="27432" marB="27432" anchor="ctr">
                     <a:solidFill>
                       <a:srgbClr val="FFFFFF"/>
                     </a:solidFill>
@@ -12071,7 +12095,7 @@
                       </a:r>
                     </a:p>
                   </a:txBody>
-                  <a:tcPr marL="146304" marR="146304" marT="64008" marB="64008" anchor="ctr">
+                  <a:tcPr marL="146304" marR="146304" marT="27432" marB="27432" anchor="ctr">
                     <a:solidFill>
                       <a:srgbClr val="FFFFFF"/>
                     </a:solidFill>
@@ -12106,7 +12130,7 @@
                       </a:r>
                     </a:p>
                   </a:txBody>
-                  <a:tcPr marL="146304" marR="146304" marT="64008" marB="64008" anchor="ctr">
+                  <a:tcPr marL="146304" marR="146304" marT="27432" marB="27432" anchor="ctr">
                     <a:solidFill>
                       <a:srgbClr val="F5F7FA"/>
                     </a:solidFill>
@@ -12139,7 +12163,7 @@
                       </a:r>
                     </a:p>
                   </a:txBody>
-                  <a:tcPr marL="146304" marR="146304" marT="64008" marB="64008" anchor="ctr">
+                  <a:tcPr marL="146304" marR="146304" marT="27432" marB="27432" anchor="ctr">
                     <a:solidFill>
                       <a:srgbClr val="F5F7FA"/>
                     </a:solidFill>
@@ -12174,7 +12198,7 @@
                       </a:r>
                     </a:p>
                   </a:txBody>
-                  <a:tcPr marL="146304" marR="146304" marT="64008" marB="64008" anchor="ctr">
+                  <a:tcPr marL="146304" marR="146304" marT="27432" marB="27432" anchor="ctr">
                     <a:solidFill>
                       <a:srgbClr val="FFFFFF"/>
                     </a:solidFill>
@@ -12207,7 +12231,7 @@
                       </a:r>
                     </a:p>
                   </a:txBody>
-                  <a:tcPr marL="146304" marR="146304" marT="64008" marB="64008" anchor="ctr">
+                  <a:tcPr marL="146304" marR="146304" marT="27432" marB="27432" anchor="ctr">
                     <a:solidFill>
                       <a:srgbClr val="FFFFFF"/>
                     </a:solidFill>
@@ -12242,7 +12266,7 @@
                       </a:r>
                     </a:p>
                   </a:txBody>
-                  <a:tcPr marL="146304" marR="146304" marT="64008" marB="64008" anchor="ctr">
+                  <a:tcPr marL="146304" marR="146304" marT="27432" marB="27432" anchor="ctr">
                     <a:solidFill>
                       <a:srgbClr val="F5F7FA"/>
                     </a:solidFill>
@@ -12275,7 +12299,7 @@
                       </a:r>
                     </a:p>
                   </a:txBody>
-                  <a:tcPr marL="146304" marR="146304" marT="64008" marB="64008" anchor="ctr">
+                  <a:tcPr marL="146304" marR="146304" marT="27432" marB="27432" anchor="ctr">
                     <a:solidFill>
                       <a:srgbClr val="F5F7FA"/>
                     </a:solidFill>
@@ -12310,7 +12334,7 @@
                       </a:r>
                     </a:p>
                   </a:txBody>
-                  <a:tcPr marL="146304" marR="146304" marT="64008" marB="64008" anchor="ctr">
+                  <a:tcPr marL="146304" marR="146304" marT="27432" marB="27432" anchor="ctr">
                     <a:solidFill>
                       <a:srgbClr val="FFFFFF"/>
                     </a:solidFill>
@@ -12343,7 +12367,7 @@
                       </a:r>
                     </a:p>
                   </a:txBody>
-                  <a:tcPr marL="146304" marR="146304" marT="64008" marB="64008" anchor="ctr">
+                  <a:tcPr marL="146304" marR="146304" marT="27432" marB="27432" anchor="ctr">
                     <a:solidFill>
                       <a:srgbClr val="FFFFFF"/>
                     </a:solidFill>
@@ -12378,7 +12402,7 @@
                       </a:r>
                     </a:p>
                   </a:txBody>
-                  <a:tcPr marL="146304" marR="146304" marT="64008" marB="64008" anchor="ctr">
+                  <a:tcPr marL="146304" marR="146304" marT="27432" marB="27432" anchor="ctr">
                     <a:solidFill>
                       <a:srgbClr val="F5F7FA"/>
                     </a:solidFill>
@@ -12411,7 +12435,7 @@
                       </a:r>
                     </a:p>
                   </a:txBody>
-                  <a:tcPr marL="146304" marR="146304" marT="64008" marB="64008" anchor="ctr">
+                  <a:tcPr marL="146304" marR="146304" marT="27432" marB="27432" anchor="ctr">
                     <a:solidFill>
                       <a:srgbClr val="F5F7FA"/>
                     </a:solidFill>
@@ -12446,7 +12470,7 @@
                       </a:r>
                     </a:p>
                   </a:txBody>
-                  <a:tcPr marL="146304" marR="146304" marT="64008" marB="64008" anchor="ctr">
+                  <a:tcPr marL="146304" marR="146304" marT="27432" marB="27432" anchor="ctr">
                     <a:solidFill>
                       <a:srgbClr val="F5F7FA"/>
                     </a:solidFill>
@@ -12479,7 +12503,75 @@
                       </a:r>
                     </a:p>
                   </a:txBody>
-                  <a:tcPr marL="146304" marR="146304" marT="64008" marB="64008" anchor="ctr">
+                  <a:tcPr marL="146304" marR="146304" marT="27432" marB="27432" anchor="ctr">
+                    <a:solidFill>
+                      <a:srgbClr val="F5F7FA"/>
+                    </a:solidFill>
+                  </a:tcPr>
+                </a:tc>
+              </a:tr>
+              <a:tr h="438912">
+                <a:tc>
+                  <a:txBody>
+                    <a:bodyPr wrap="square"/>
+                    <a:lstStyle/>
+                    <a:p>
+                      <a:pPr algn="l">
+                        <a:lnSpc>
+                          <a:spcPct val="105000"/>
+                        </a:lnSpc>
+                        <a:spcBef>
+                          <a:spcPts val="0"/>
+                        </a:spcBef>
+                        <a:spcAft>
+                          <a:spcPts val="0"/>
+                        </a:spcAft>
+                      </a:pPr>
+                      <a:r>
+                        <a:rPr sz="1350" b="1">
+                          <a:solidFill>
+                            <a:srgbClr val="1F2933"/>
+                          </a:solidFill>
+                          <a:latin typeface="Calibri"/>
+                        </a:rPr>
+                        <a:t>Maps</a:t>
+                      </a:r>
+                    </a:p>
+                  </a:txBody>
+                  <a:tcPr marL="146304" marR="146304" marT="27432" marB="27432" anchor="ctr">
+                    <a:solidFill>
+                      <a:srgbClr val="F5F7FA"/>
+                    </a:solidFill>
+                  </a:tcPr>
+                </a:tc>
+                <a:tc>
+                  <a:txBody>
+                    <a:bodyPr wrap="square"/>
+                    <a:lstStyle/>
+                    <a:p>
+                      <a:pPr algn="l">
+                        <a:lnSpc>
+                          <a:spcPct val="105000"/>
+                        </a:lnSpc>
+                        <a:spcBef>
+                          <a:spcPts val="0"/>
+                        </a:spcBef>
+                        <a:spcAft>
+                          <a:spcPts val="0"/>
+                        </a:spcAft>
+                      </a:pPr>
+                      <a:r>
+                        <a:rPr sz="1300" b="0">
+                          <a:solidFill>
+                            <a:srgbClr val="3E4C59"/>
+                          </a:solidFill>
+                          <a:latin typeface="Calibri"/>
+                        </a:rPr>
+                        <a:t>OpenStreetMap or your own tile server, cached by the gateway; plans from any picture; PTZ and fixed cameras calibrated by landmarks</a:t>
+                      </a:r>
+                    </a:p>
+                  </a:txBody>
+                  <a:tcPr marL="146304" marR="146304" marT="27432" marB="27432" anchor="ctr">
                     <a:solidFill>
                       <a:srgbClr val="F5F7FA"/>
                     </a:solidFill>
@@ -12620,7 +12712,7 @@
                 </a:solidFill>
                 <a:latin typeface="Calibri"/>
               </a:rPr>
-              <a:t>32</a:t>
+              <a:t>34</a:t>
             </a:r>
           </a:p>
         </p:txBody>
@@ -12972,7 +13064,7 @@
                 </a:solidFill>
                 <a:latin typeface="Calibri"/>
               </a:rPr>
-              <a:t>33</a:t>
+              <a:t>35</a:t>
             </a:r>
           </a:p>
         </p:txBody>
@@ -13146,7 +13238,7 @@
                 </a:solidFill>
                 <a:latin typeface="Calibri"/>
               </a:rPr>
-              <a:t>•   New: the camera follows an object by itself, a person or a vehicle can be looked for across every camera at once, and the archive takes noticeably less space — while plates and faces stay readable.</a:t>
+              <a:t>•   New: cameras on a map of the site, the camera follows an object by itself, a person or a vehicle can be looked for across every camera at once, and the archive takes noticeably less space — while plates and faces stay readable.</a:t>
             </a:r>
           </a:p>
           <a:p>
@@ -13401,7 +13493,7 @@
                 </a:solidFill>
                 <a:latin typeface="Calibri"/>
               </a:rPr>
-              <a:t>34</a:t>
+              <a:t>36</a:t>
             </a:r>
           </a:p>
         </p:txBody>
@@ -14083,7 +14175,849 @@
                 </a:solidFill>
                 <a:latin typeface="Calibri"/>
               </a:rPr>
-              <a:t>14</a:t>
+              <a:t>16</a:t>
+            </a:r>
+          </a:p>
+        </p:txBody>
+      </p:sp>
+    </p:spTree>
+  </p:cSld>
+  <p:clrMapOvr>
+    <a:masterClrMapping/>
+  </p:clrMapOvr>
+</p:sld>
+</file>
+
+<file path=ppt/slides/slide35.xml><?xml version="1.0" encoding="utf-8"?>
+<p:sld xmlns:a="http://schemas.openxmlformats.org/drawingml/2006/main" xmlns:p="http://schemas.openxmlformats.org/presentationml/2006/main" xmlns:r="http://schemas.openxmlformats.org/officeDocument/2006/relationships">
+  <p:cSld>
+    <p:spTree>
+      <p:nvGrpSpPr>
+        <p:cNvPr id="1" name=""/>
+        <p:cNvGrpSpPr/>
+        <p:nvPr/>
+      </p:nvGrpSpPr>
+      <p:grpSpPr/>
+      <p:sp>
+        <p:nvSpPr>
+          <p:cNvPr id="2" name="TextBox 1"/>
+          <p:cNvSpPr txBox="1"/>
+          <p:nvPr/>
+        </p:nvSpPr>
+        <p:spPr>
+          <a:xfrm>
+            <a:off x="685800" y="475488"/>
+            <a:ext cx="10820095" cy="868680"/>
+          </a:xfrm>
+          <a:prstGeom prst="rect">
+            <a:avLst/>
+          </a:prstGeom>
+          <a:noFill/>
+        </p:spPr>
+        <p:txBody>
+          <a:bodyPr wrap="square" lIns="0" rIns="0" tIns="0" bIns="0" anchor="t">
+            <a:spAutoFit/>
+          </a:bodyPr>
+          <a:lstStyle/>
+          <a:p>
+            <a:pPr algn="l">
+              <a:lnSpc>
+                <a:spcPct val="95000"/>
+              </a:lnSpc>
+              <a:spcBef>
+                <a:spcPts val="0"/>
+              </a:spcBef>
+              <a:spcAft>
+                <a:spcPts val="0"/>
+              </a:spcAft>
+            </a:pPr>
+            <a:r>
+              <a:rPr sz="3000" b="1">
+                <a:solidFill>
+                  <a:srgbClr val="1F2933"/>
+                </a:solidFill>
+                <a:latin typeface="Calibri"/>
+              </a:rPr>
+              <a:t>Cameras on a map of the site</a:t>
+            </a:r>
+          </a:p>
+        </p:txBody>
+      </p:sp>
+      <p:sp>
+        <p:nvSpPr>
+          <p:cNvPr id="3" name="Rectangle 2"/>
+          <p:cNvSpPr/>
+          <p:nvPr/>
+        </p:nvSpPr>
+        <p:spPr>
+          <a:xfrm>
+            <a:off x="685800" y="1243584"/>
+            <a:ext cx="1051560" cy="50292"/>
+          </a:xfrm>
+          <a:prstGeom prst="rect">
+            <a:avLst/>
+          </a:prstGeom>
+          <a:solidFill>
+            <a:srgbClr val="D6291E"/>
+          </a:solidFill>
+          <a:ln>
+            <a:noFill/>
+          </a:ln>
+          <a:effectLst/>
+        </p:spPr>
+        <p:style>
+          <a:lnRef idx="1">
+            <a:schemeClr val="accent1"/>
+          </a:lnRef>
+          <a:fillRef idx="3">
+            <a:schemeClr val="accent1"/>
+          </a:fillRef>
+          <a:effectRef idx="2">
+            <a:schemeClr val="accent1"/>
+          </a:effectRef>
+          <a:fontRef idx="minor">
+            <a:schemeClr val="lt1"/>
+          </a:fontRef>
+        </p:style>
+        <p:txBody>
+          <a:bodyPr rtlCol="0" anchor="ctr"/>
+          <a:lstStyle/>
+          <a:p>
+            <a:pPr algn="ctr"/>
+          </a:p>
+        </p:txBody>
+      </p:sp>
+      <p:sp>
+        <p:nvSpPr>
+          <p:cNvPr id="4" name="TextBox 3"/>
+          <p:cNvSpPr txBox="1"/>
+          <p:nvPr/>
+        </p:nvSpPr>
+        <p:spPr>
+          <a:xfrm>
+            <a:off x="685800" y="1572768"/>
+            <a:ext cx="5989320" cy="4690872"/>
+          </a:xfrm>
+          <a:prstGeom prst="rect">
+            <a:avLst/>
+          </a:prstGeom>
+          <a:noFill/>
+        </p:spPr>
+        <p:txBody>
+          <a:bodyPr wrap="square" lIns="0" rIns="0" tIns="0" bIns="0" anchor="ctr">
+            <a:spAutoFit/>
+          </a:bodyPr>
+          <a:lstStyle/>
+          <a:p>
+            <a:pPr algn="l" marL="237744" indent="-237744">
+              <a:lnSpc>
+                <a:spcPct val="112000"/>
+              </a:lnSpc>
+              <a:spcBef>
+                <a:spcPts val="0"/>
+              </a:spcBef>
+              <a:spcAft>
+                <a:spcPts val="1100"/>
+              </a:spcAft>
+            </a:pPr>
+            <a:r>
+              <a:rPr sz="1450" b="0">
+                <a:solidFill>
+                  <a:srgbClr val="3E4C59"/>
+                </a:solidFill>
+                <a:latin typeface="Calibri"/>
+              </a:rPr>
+              <a:t>•   Every camera is shown where it really stands, with the area it sees drawn on the map. A building gets its own plans, floor by floor — any picture will do: a floor plan, a drawing, a photo from above.</a:t>
+            </a:r>
+          </a:p>
+          <a:p>
+            <a:pPr algn="l" marL="237744" indent="-237744">
+              <a:lnSpc>
+                <a:spcPct val="112000"/>
+              </a:lnSpc>
+              <a:spcBef>
+                <a:spcPts val="0"/>
+              </a:spcBef>
+              <a:spcAft>
+                <a:spcPts val="1100"/>
+              </a:spcAft>
+            </a:pPr>
+            <a:r>
+              <a:rPr sz="1450" b="0">
+                <a:solidFill>
+                  <a:srgbClr val="3E4C59"/>
+                </a:solidFill>
+                <a:latin typeface="Calibri"/>
+              </a:rPr>
+              <a:t>•   Click a camera and its live picture opens beside the map. Recent alarms are listed next to it, each a click away from its camera.</a:t>
+            </a:r>
+          </a:p>
+          <a:p>
+            <a:pPr algn="l" marL="237744" indent="-237744">
+              <a:lnSpc>
+                <a:spcPct val="112000"/>
+              </a:lnSpc>
+              <a:spcBef>
+                <a:spcPts val="0"/>
+              </a:spcBef>
+              <a:spcAft>
+                <a:spcPts val="1100"/>
+              </a:spcAft>
+            </a:pPr>
+            <a:r>
+              <a:rPr sz="1450" b="0">
+                <a:solidFill>
+                  <a:srgbClr val="3E4C59"/>
+                </a:solidFill>
+                <a:latin typeface="Calibri"/>
+              </a:rPr>
+              <a:t>•   People seen by a fixed camera show up on the map as dots, where they stand — the same colour as their frame on the video.</a:t>
+            </a:r>
+          </a:p>
+          <a:p>
+            <a:pPr algn="l" marL="237744" indent="-237744">
+              <a:lnSpc>
+                <a:spcPct val="112000"/>
+              </a:lnSpc>
+              <a:spcBef>
+                <a:spcPts val="0"/>
+              </a:spcBef>
+              <a:spcAft>
+                <a:spcPts val="1100"/>
+              </a:spcAft>
+            </a:pPr>
+            <a:r>
+              <a:rPr sz="1450" b="0">
+                <a:solidFill>
+                  <a:srgbClr val="3E4C59"/>
+                </a:solidFill>
+                <a:latin typeface="Calibri"/>
+              </a:rPr>
+              <a:t>•   Click a place on the map, and a PTZ camera turns to look at it.</a:t>
+            </a:r>
+          </a:p>
+        </p:txBody>
+      </p:sp>
+      <p:sp>
+        <p:nvSpPr>
+          <p:cNvPr id="5" name="Rectangle 4"/>
+          <p:cNvSpPr/>
+          <p:nvPr/>
+        </p:nvSpPr>
+        <p:spPr>
+          <a:xfrm>
+            <a:off x="7100316" y="1957101"/>
+            <a:ext cx="4437583" cy="2797492"/>
+          </a:xfrm>
+          <a:prstGeom prst="rect">
+            <a:avLst/>
+          </a:prstGeom>
+          <a:solidFill>
+            <a:srgbClr val="CBD2D9"/>
+          </a:solidFill>
+          <a:ln>
+            <a:noFill/>
+          </a:ln>
+          <a:effectLst/>
+        </p:spPr>
+        <p:style>
+          <a:lnRef idx="1">
+            <a:schemeClr val="accent1"/>
+          </a:lnRef>
+          <a:fillRef idx="3">
+            <a:schemeClr val="accent1"/>
+          </a:fillRef>
+          <a:effectRef idx="2">
+            <a:schemeClr val="accent1"/>
+          </a:effectRef>
+          <a:fontRef idx="minor">
+            <a:schemeClr val="lt1"/>
+          </a:fontRef>
+        </p:style>
+        <p:txBody>
+          <a:bodyPr rtlCol="0" anchor="ctr"/>
+          <a:lstStyle/>
+          <a:p>
+            <a:pPr algn="ctr"/>
+          </a:p>
+        </p:txBody>
+      </p:sp>
+      <p:pic>
+        <p:nvPicPr>
+          <p:cNvPr id="6" name="Picture 5" descr="The map of the site: a fixed camera and a PTZ with the areas they see, a person as a dot where they stand, and the PTZ's own picture of them."/>
+          <p:cNvPicPr>
+            <a:picLocks noChangeAspect="1"/>
+          </p:cNvPicPr>
+          <p:nvPr/>
+        </p:nvPicPr>
+        <p:blipFill>
+          <a:blip r:embed="rId2"/>
+          <a:stretch>
+            <a:fillRect/>
+          </a:stretch>
+        </p:blipFill>
+        <p:spPr>
+          <a:xfrm>
+            <a:off x="7132320" y="1989105"/>
+            <a:ext cx="4373575" cy="2733484"/>
+          </a:xfrm>
+          <a:prstGeom prst="rect">
+            <a:avLst/>
+          </a:prstGeom>
+        </p:spPr>
+      </p:pic>
+      <p:sp>
+        <p:nvSpPr>
+          <p:cNvPr id="7" name="TextBox 6"/>
+          <p:cNvSpPr txBox="1"/>
+          <p:nvPr/>
+        </p:nvSpPr>
+        <p:spPr>
+          <a:xfrm>
+            <a:off x="7132320" y="4923758"/>
+            <a:ext cx="4373575" cy="1280160"/>
+          </a:xfrm>
+          <a:prstGeom prst="rect">
+            <a:avLst/>
+          </a:prstGeom>
+          <a:noFill/>
+        </p:spPr>
+        <p:txBody>
+          <a:bodyPr wrap="square" lIns="0" rIns="0" tIns="0" bIns="0" anchor="t">
+            <a:spAutoFit/>
+          </a:bodyPr>
+          <a:lstStyle/>
+          <a:p>
+            <a:pPr algn="l">
+              <a:lnSpc>
+                <a:spcPct val="115000"/>
+              </a:lnSpc>
+              <a:spcBef>
+                <a:spcPts val="0"/>
+              </a:spcBef>
+              <a:spcAft>
+                <a:spcPts val="0"/>
+              </a:spcAft>
+            </a:pPr>
+            <a:r>
+              <a:rPr sz="1150" b="0">
+                <a:solidFill>
+                  <a:srgbClr val="7B8794"/>
+                </a:solidFill>
+                <a:latin typeface="Calibri"/>
+              </a:rPr>
+              <a:t>The map of the site: a fixed camera and a PTZ with the areas they see, a person as a dot where they stand, and the PTZ's own picture of them.</a:t>
+            </a:r>
+          </a:p>
+        </p:txBody>
+      </p:sp>
+      <p:sp>
+        <p:nvSpPr>
+          <p:cNvPr id="8" name="TextBox 7"/>
+          <p:cNvSpPr txBox="1"/>
+          <p:nvPr/>
+        </p:nvSpPr>
+        <p:spPr>
+          <a:xfrm>
+            <a:off x="685800" y="6355080"/>
+            <a:ext cx="10820095" cy="274320"/>
+          </a:xfrm>
+          <a:prstGeom prst="rect">
+            <a:avLst/>
+          </a:prstGeom>
+          <a:noFill/>
+        </p:spPr>
+        <p:txBody>
+          <a:bodyPr wrap="square" lIns="0" rIns="0" tIns="0" bIns="0" anchor="t">
+            <a:spAutoFit/>
+          </a:bodyPr>
+          <a:lstStyle/>
+          <a:p>
+            <a:pPr algn="l">
+              <a:lnSpc>
+                <a:spcPct val="100000"/>
+              </a:lnSpc>
+              <a:spcBef>
+                <a:spcPts val="0"/>
+              </a:spcBef>
+              <a:spcAft>
+                <a:spcPts val="0"/>
+              </a:spcAft>
+            </a:pPr>
+            <a:r>
+              <a:rPr sz="900" b="0">
+                <a:solidFill>
+                  <a:srgbClr val="7B8794"/>
+                </a:solidFill>
+                <a:latin typeface="Calibri"/>
+              </a:rPr>
+              <a:t>TreeAlarm VMS · treealarm.dev</a:t>
+            </a:r>
+          </a:p>
+        </p:txBody>
+      </p:sp>
+      <p:sp>
+        <p:nvSpPr>
+          <p:cNvPr id="9" name="TextBox 8"/>
+          <p:cNvSpPr txBox="1"/>
+          <p:nvPr/>
+        </p:nvSpPr>
+        <p:spPr>
+          <a:xfrm>
+            <a:off x="10591495" y="6355080"/>
+            <a:ext cx="914400" cy="274320"/>
+          </a:xfrm>
+          <a:prstGeom prst="rect">
+            <a:avLst/>
+          </a:prstGeom>
+          <a:noFill/>
+        </p:spPr>
+        <p:txBody>
+          <a:bodyPr wrap="square" lIns="0" rIns="0" tIns="0" bIns="0" anchor="t">
+            <a:spAutoFit/>
+          </a:bodyPr>
+          <a:lstStyle/>
+          <a:p>
+            <a:pPr algn="r">
+              <a:lnSpc>
+                <a:spcPct val="100000"/>
+              </a:lnSpc>
+              <a:spcBef>
+                <a:spcPts val="0"/>
+              </a:spcBef>
+              <a:spcAft>
+                <a:spcPts val="0"/>
+              </a:spcAft>
+            </a:pPr>
+            <a:r>
+              <a:rPr sz="900" b="0">
+                <a:solidFill>
+                  <a:srgbClr val="7B8794"/>
+                </a:solidFill>
+                <a:latin typeface="Calibri"/>
+              </a:rPr>
+              <a:t>8</a:t>
+            </a:r>
+          </a:p>
+        </p:txBody>
+      </p:sp>
+    </p:spTree>
+  </p:cSld>
+  <p:clrMapOvr>
+    <a:masterClrMapping/>
+  </p:clrMapOvr>
+</p:sld>
+</file>
+
+<file path=ppt/slides/slide36.xml><?xml version="1.0" encoding="utf-8"?>
+<p:sld xmlns:a="http://schemas.openxmlformats.org/drawingml/2006/main" xmlns:p="http://schemas.openxmlformats.org/presentationml/2006/main" xmlns:r="http://schemas.openxmlformats.org/officeDocument/2006/relationships">
+  <p:cSld>
+    <p:spTree>
+      <p:nvGrpSpPr>
+        <p:cNvPr id="1" name=""/>
+        <p:cNvGrpSpPr/>
+        <p:nvPr/>
+      </p:nvGrpSpPr>
+      <p:grpSpPr/>
+      <p:sp>
+        <p:nvSpPr>
+          <p:cNvPr id="2" name="TextBox 1"/>
+          <p:cNvSpPr txBox="1"/>
+          <p:nvPr/>
+        </p:nvSpPr>
+        <p:spPr>
+          <a:xfrm>
+            <a:off x="685800" y="475488"/>
+            <a:ext cx="10820095" cy="868680"/>
+          </a:xfrm>
+          <a:prstGeom prst="rect">
+            <a:avLst/>
+          </a:prstGeom>
+          <a:noFill/>
+        </p:spPr>
+        <p:txBody>
+          <a:bodyPr wrap="square" lIns="0" rIns="0" tIns="0" bIns="0" anchor="t">
+            <a:spAutoFit/>
+          </a:bodyPr>
+          <a:lstStyle/>
+          <a:p>
+            <a:pPr algn="l">
+              <a:lnSpc>
+                <a:spcPct val="95000"/>
+              </a:lnSpc>
+              <a:spcBef>
+                <a:spcPts val="0"/>
+              </a:spcBef>
+              <a:spcAft>
+                <a:spcPts val="0"/>
+              </a:spcAft>
+            </a:pPr>
+            <a:r>
+              <a:rPr sz="3000" b="1">
+                <a:solidFill>
+                  <a:srgbClr val="1F2933"/>
+                </a:solidFill>
+                <a:latin typeface="Calibri"/>
+              </a:rPr>
+              <a:t>One camera notices, the other takes a closer look</a:t>
+            </a:r>
+          </a:p>
+        </p:txBody>
+      </p:sp>
+      <p:sp>
+        <p:nvSpPr>
+          <p:cNvPr id="3" name="Rectangle 2"/>
+          <p:cNvSpPr/>
+          <p:nvPr/>
+        </p:nvSpPr>
+        <p:spPr>
+          <a:xfrm>
+            <a:off x="685800" y="1243584"/>
+            <a:ext cx="1051560" cy="50292"/>
+          </a:xfrm>
+          <a:prstGeom prst="rect">
+            <a:avLst/>
+          </a:prstGeom>
+          <a:solidFill>
+            <a:srgbClr val="D6291E"/>
+          </a:solidFill>
+          <a:ln>
+            <a:noFill/>
+          </a:ln>
+          <a:effectLst/>
+        </p:spPr>
+        <p:style>
+          <a:lnRef idx="1">
+            <a:schemeClr val="accent1"/>
+          </a:lnRef>
+          <a:fillRef idx="3">
+            <a:schemeClr val="accent1"/>
+          </a:fillRef>
+          <a:effectRef idx="2">
+            <a:schemeClr val="accent1"/>
+          </a:effectRef>
+          <a:fontRef idx="minor">
+            <a:schemeClr val="lt1"/>
+          </a:fontRef>
+        </p:style>
+        <p:txBody>
+          <a:bodyPr rtlCol="0" anchor="ctr"/>
+          <a:lstStyle/>
+          <a:p>
+            <a:pPr algn="ctr"/>
+          </a:p>
+        </p:txBody>
+      </p:sp>
+      <p:sp>
+        <p:nvSpPr>
+          <p:cNvPr id="4" name="TextBox 3"/>
+          <p:cNvSpPr txBox="1"/>
+          <p:nvPr/>
+        </p:nvSpPr>
+        <p:spPr>
+          <a:xfrm>
+            <a:off x="685800" y="1572768"/>
+            <a:ext cx="5989320" cy="4690872"/>
+          </a:xfrm>
+          <a:prstGeom prst="rect">
+            <a:avLst/>
+          </a:prstGeom>
+          <a:noFill/>
+        </p:spPr>
+        <p:txBody>
+          <a:bodyPr wrap="square" lIns="0" rIns="0" tIns="0" bIns="0" anchor="ctr">
+            <a:spAutoFit/>
+          </a:bodyPr>
+          <a:lstStyle/>
+          <a:p>
+            <a:pPr algn="l" marL="237744" indent="-237744">
+              <a:lnSpc>
+                <a:spcPct val="112000"/>
+              </a:lnSpc>
+              <a:spcBef>
+                <a:spcPts val="0"/>
+              </a:spcBef>
+              <a:spcAft>
+                <a:spcPts val="1100"/>
+              </a:spcAft>
+            </a:pPr>
+            <a:r>
+              <a:rPr sz="1450" b="0">
+                <a:solidFill>
+                  <a:srgbClr val="3E4C59"/>
+                </a:solidFill>
+                <a:latin typeface="Calibri"/>
+              </a:rPr>
+              <a:t>•   A fixed camera watches a wide area, and a PTZ camera beside it does the close-ups. When the fixed camera sees a person, the PTZ turns to them by itself and keeps them in frame.</a:t>
+            </a:r>
+          </a:p>
+          <a:p>
+            <a:pPr algn="l" marL="237744" indent="-237744">
+              <a:lnSpc>
+                <a:spcPct val="112000"/>
+              </a:lnSpc>
+              <a:spcBef>
+                <a:spcPts val="0"/>
+              </a:spcBef>
+              <a:spcAft>
+                <a:spcPts val="1100"/>
+              </a:spcAft>
+            </a:pPr>
+            <a:r>
+              <a:rPr sz="1450" b="0">
+                <a:solidFill>
+                  <a:srgbClr val="3E4C59"/>
+                </a:solidFill>
+                <a:latin typeface="Calibri"/>
+              </a:rPr>
+              <a:t>•   It zooms by distance: the farther away the person, the closer it brings them, so they stay the same size in frame as they walk.</a:t>
+            </a:r>
+          </a:p>
+          <a:p>
+            <a:pPr algn="l" marL="237744" indent="-237744">
+              <a:lnSpc>
+                <a:spcPct val="112000"/>
+              </a:lnSpc>
+              <a:spcBef>
+                <a:spcPts val="0"/>
+              </a:spcBef>
+              <a:spcAft>
+                <a:spcPts val="1100"/>
+              </a:spcAft>
+            </a:pPr>
+            <a:r>
+              <a:rPr sz="1450" b="0">
+                <a:solidFill>
+                  <a:srgbClr val="3E4C59"/>
+                </a:solidFill>
+                <a:latin typeface="Calibri"/>
+              </a:rPr>
+              <a:t>•   Setting it up is a few marks on the map — a corner, a post, a hatch — not measuring. Each camera is set up once, on its own, and any pair then works together.</a:t>
+            </a:r>
+          </a:p>
+          <a:p>
+            <a:pPr algn="l" marL="237744" indent="-237744">
+              <a:lnSpc>
+                <a:spcPct val="112000"/>
+              </a:lnSpc>
+              <a:spcBef>
+                <a:spcPts val="0"/>
+              </a:spcBef>
+              <a:spcAft>
+                <a:spcPts val="1100"/>
+              </a:spcAft>
+            </a:pPr>
+            <a:r>
+              <a:rPr sz="1450" b="0">
+                <a:solidFill>
+                  <a:srgbClr val="3E4C59"/>
+                </a:solidFill>
+                <a:latin typeface="Calibri"/>
+              </a:rPr>
+              <a:t>•   A street map is not required: the same works on a plan drawn over any picture, as here.</a:t>
+            </a:r>
+          </a:p>
+        </p:txBody>
+      </p:sp>
+      <p:sp>
+        <p:nvSpPr>
+          <p:cNvPr id="5" name="Rectangle 4"/>
+          <p:cNvSpPr/>
+          <p:nvPr/>
+        </p:nvSpPr>
+        <p:spPr>
+          <a:xfrm>
+            <a:off x="7100316" y="1957101"/>
+            <a:ext cx="4437583" cy="2797492"/>
+          </a:xfrm>
+          <a:prstGeom prst="rect">
+            <a:avLst/>
+          </a:prstGeom>
+          <a:solidFill>
+            <a:srgbClr val="CBD2D9"/>
+          </a:solidFill>
+          <a:ln>
+            <a:noFill/>
+          </a:ln>
+          <a:effectLst/>
+        </p:spPr>
+        <p:style>
+          <a:lnRef idx="1">
+            <a:schemeClr val="accent1"/>
+          </a:lnRef>
+          <a:fillRef idx="3">
+            <a:schemeClr val="accent1"/>
+          </a:fillRef>
+          <a:effectRef idx="2">
+            <a:schemeClr val="accent1"/>
+          </a:effectRef>
+          <a:fontRef idx="minor">
+            <a:schemeClr val="lt1"/>
+          </a:fontRef>
+        </p:style>
+        <p:txBody>
+          <a:bodyPr rtlCol="0" anchor="ctr"/>
+          <a:lstStyle/>
+          <a:p>
+            <a:pPr algn="ctr"/>
+          </a:p>
+        </p:txBody>
+      </p:sp>
+      <p:pic>
+        <p:nvPicPr>
+          <p:cNvPr id="6" name="Picture 5" descr="A plan drawn over a picture from above: the fixed camera's view, the person as a dot, and the PTZ already looking at them. Shown on OnvifSim, our camera simulator."/>
+          <p:cNvPicPr>
+            <a:picLocks noChangeAspect="1"/>
+          </p:cNvPicPr>
+          <p:nvPr/>
+        </p:nvPicPr>
+        <p:blipFill>
+          <a:blip r:embed="rId2"/>
+          <a:stretch>
+            <a:fillRect/>
+          </a:stretch>
+        </p:blipFill>
+        <p:spPr>
+          <a:xfrm>
+            <a:off x="7132320" y="1989105"/>
+            <a:ext cx="4373575" cy="2733484"/>
+          </a:xfrm>
+          <a:prstGeom prst="rect">
+            <a:avLst/>
+          </a:prstGeom>
+        </p:spPr>
+      </p:pic>
+      <p:sp>
+        <p:nvSpPr>
+          <p:cNvPr id="7" name="TextBox 6"/>
+          <p:cNvSpPr txBox="1"/>
+          <p:nvPr/>
+        </p:nvSpPr>
+        <p:spPr>
+          <a:xfrm>
+            <a:off x="7132320" y="4923758"/>
+            <a:ext cx="4373575" cy="1280160"/>
+          </a:xfrm>
+          <a:prstGeom prst="rect">
+            <a:avLst/>
+          </a:prstGeom>
+          <a:noFill/>
+        </p:spPr>
+        <p:txBody>
+          <a:bodyPr wrap="square" lIns="0" rIns="0" tIns="0" bIns="0" anchor="t">
+            <a:spAutoFit/>
+          </a:bodyPr>
+          <a:lstStyle/>
+          <a:p>
+            <a:pPr algn="l">
+              <a:lnSpc>
+                <a:spcPct val="115000"/>
+              </a:lnSpc>
+              <a:spcBef>
+                <a:spcPts val="0"/>
+              </a:spcBef>
+              <a:spcAft>
+                <a:spcPts val="0"/>
+              </a:spcAft>
+            </a:pPr>
+            <a:r>
+              <a:rPr sz="1150" b="0">
+                <a:solidFill>
+                  <a:srgbClr val="7B8794"/>
+                </a:solidFill>
+                <a:latin typeface="Calibri"/>
+              </a:rPr>
+              <a:t>A plan drawn over a picture from above: the fixed camera's view, the person as a dot, and the PTZ already looking at them. Shown on OnvifSim, our camera simulator.</a:t>
+            </a:r>
+          </a:p>
+        </p:txBody>
+      </p:sp>
+      <p:sp>
+        <p:nvSpPr>
+          <p:cNvPr id="8" name="TextBox 7"/>
+          <p:cNvSpPr txBox="1"/>
+          <p:nvPr/>
+        </p:nvSpPr>
+        <p:spPr>
+          <a:xfrm>
+            <a:off x="685800" y="6355080"/>
+            <a:ext cx="10820095" cy="274320"/>
+          </a:xfrm>
+          <a:prstGeom prst="rect">
+            <a:avLst/>
+          </a:prstGeom>
+          <a:noFill/>
+        </p:spPr>
+        <p:txBody>
+          <a:bodyPr wrap="square" lIns="0" rIns="0" tIns="0" bIns="0" anchor="t">
+            <a:spAutoFit/>
+          </a:bodyPr>
+          <a:lstStyle/>
+          <a:p>
+            <a:pPr algn="l">
+              <a:lnSpc>
+                <a:spcPct val="100000"/>
+              </a:lnSpc>
+              <a:spcBef>
+                <a:spcPts val="0"/>
+              </a:spcBef>
+              <a:spcAft>
+                <a:spcPts val="0"/>
+              </a:spcAft>
+            </a:pPr>
+            <a:r>
+              <a:rPr sz="900" b="0">
+                <a:solidFill>
+                  <a:srgbClr val="7B8794"/>
+                </a:solidFill>
+                <a:latin typeface="Calibri"/>
+              </a:rPr>
+              <a:t>TreeAlarm VMS · treealarm.dev</a:t>
+            </a:r>
+          </a:p>
+        </p:txBody>
+      </p:sp>
+      <p:sp>
+        <p:nvSpPr>
+          <p:cNvPr id="9" name="TextBox 8"/>
+          <p:cNvSpPr txBox="1"/>
+          <p:nvPr/>
+        </p:nvSpPr>
+        <p:spPr>
+          <a:xfrm>
+            <a:off x="10591495" y="6355080"/>
+            <a:ext cx="914400" cy="274320"/>
+          </a:xfrm>
+          <a:prstGeom prst="rect">
+            <a:avLst/>
+          </a:prstGeom>
+          <a:noFill/>
+        </p:spPr>
+        <p:txBody>
+          <a:bodyPr wrap="square" lIns="0" rIns="0" tIns="0" bIns="0" anchor="t">
+            <a:spAutoFit/>
+          </a:bodyPr>
+          <a:lstStyle/>
+          <a:p>
+            <a:pPr algn="r">
+              <a:lnSpc>
+                <a:spcPct val="100000"/>
+              </a:lnSpc>
+              <a:spcBef>
+                <a:spcPts val="0"/>
+              </a:spcBef>
+              <a:spcAft>
+                <a:spcPts val="0"/>
+              </a:spcAft>
+            </a:pPr>
+            <a:r>
+              <a:rPr sz="900" b="0">
+                <a:solidFill>
+                  <a:srgbClr val="7B8794"/>
+                </a:solidFill>
+                <a:latin typeface="Calibri"/>
+              </a:rPr>
+              <a:t>9</a:t>
             </a:r>
           </a:p>
         </p:txBody>
@@ -15494,7 +16428,7 @@
                 </a:solidFill>
                 <a:latin typeface="Calibri"/>
               </a:rPr>
-              <a:t>8</a:t>
+              <a:t>10</a:t>
             </a:r>
           </a:p>
         </p:txBody>
@@ -15915,7 +16849,7 @@
                 </a:solidFill>
                 <a:latin typeface="Calibri"/>
               </a:rPr>
-              <a:t>9</a:t>
+              <a:t>11</a:t>
             </a:r>
           </a:p>
         </p:txBody>
@@ -16314,7 +17248,7 @@
                 </a:solidFill>
                 <a:latin typeface="Calibri"/>
               </a:rPr>
-              <a:t>10</a:t>
+              <a:t>12</a:t>
             </a:r>
           </a:p>
         </p:txBody>

</xml_diff>